<commit_message>
Fix Word lists and PPT table merges found in visual tests.
python-docx ListBullet/ListNumber styles have no w:numPr, so bullets
were rendered as plain paragraphs. Floating images leaked into later
blocks via CSS float. PPT titles still fell back to concatenated table
text, and python-pptx writes gridSpan/hMerge on a:tc attributes.

Co-authored-by: EthanBird <EthanBird@users.noreply.github.com>
</commit_message>
<xml_diff>
--- a/public/office-fixtures/leafmark-sample.pptx
+++ b/public/office-fixtures/leafmark-sample.pptx
@@ -3122,8 +3122,8 @@
         </p:nvSpPr>
         <p:spPr>
           <a:xfrm>
-            <a:off x="640080" y="2011680"/>
-            <a:ext cx="7680960" cy="1280160"/>
+            <a:off x="640080" y="1874519"/>
+            <a:ext cx="8778240" cy="1097280"/>
           </a:xfrm>
           <a:prstGeom prst="rect">
             <a:avLst/>
@@ -3156,8 +3156,8 @@
         </p:nvSpPr>
         <p:spPr>
           <a:xfrm>
-            <a:off x="640080" y="3291840"/>
-            <a:ext cx="8412480" cy="914400"/>
+            <a:off x="640080" y="3063240"/>
+            <a:ext cx="8778240" cy="640080"/>
           </a:xfrm>
           <a:prstGeom prst="rect">
             <a:avLst/>
@@ -3172,12 +3172,46 @@
           <a:p>
             <a:pPr algn="l"/>
             <a:r>
-              <a:rPr sz="1800" b="0">
+              <a:rPr sz="2000" b="0">
                 <a:solidFill>
                   <a:srgbClr val="CCFBF1"/>
                 </a:solidFill>
               </a:rPr>
-              <a:t>全幅背景图 + 标题。若背景丢失，这一页会变成白底。</a:t>
+              <a:t>LeafMark 视觉样张 · 全幅背景图 + 标题文本框</a:t>
+            </a:r>
+          </a:p>
+        </p:txBody>
+      </p:sp>
+      <p:sp>
+        <p:nvSpPr>
+          <p:cNvPr id="5" name="TextBox 4"/>
+          <p:cNvSpPr txBox="1"/>
+          <p:nvPr/>
+        </p:nvSpPr>
+        <p:spPr>
+          <a:xfrm>
+            <a:off x="640080" y="3794760"/>
+            <a:ext cx="9326880" cy="914400"/>
+          </a:xfrm>
+          <a:prstGeom prst="rect">
+            <a:avLst/>
+          </a:prstGeom>
+          <a:noFill/>
+        </p:spPr>
+        <p:txBody>
+          <a:bodyPr wrap="none">
+            <a:spAutoFit/>
+          </a:bodyPr>
+          <a:lstStyle/>
+          <a:p>
+            <a:pPr algn="l"/>
+            <a:r>
+              <a:rPr sz="1600" b="0">
+                <a:solidFill>
+                  <a:srgbClr val="99F6E4"/>
+                </a:solidFill>
+              </a:rPr>
+              <a:t>若背景丢失，这一页会变成白底。标题必须来自文本框，不能只印在 PNG 里。</a:t>
             </a:r>
           </a:p>
         </p:txBody>
@@ -3275,8 +3309,8 @@
           <p:nvPr/>
         </p:nvGraphicFramePr>
         <p:xfrm>
-          <a:off x="6035040" y="1280160"/>
-          <a:ext cx="5486400" cy="2926080"/>
+          <a:off x="6035040" y="1143000"/>
+          <a:ext cx="5486400" cy="3657600"/>
         </p:xfrm>
         <a:graphic>
           <a:graphicData uri="http://schemas.openxmlformats.org/drawingml/2006/table">
@@ -3289,7 +3323,37 @@
                 <a:gridCol w="1828800"/>
                 <a:gridCol w="1828800"/>
               </a:tblGrid>
-              <a:tr h="975360">
+              <a:tr h="914400">
+                <a:tc gridSpan="3">
+                  <a:txBody>
+                    <a:bodyPr/>
+                    <a:lstStyle/>
+                    <a:p>
+                      <a:r>
+                        <a:t>对照表（跨三列）</a:t>
+                      </a:r>
+                    </a:p>
+                  </a:txBody>
+                  <a:tcPr/>
+                </a:tc>
+                <a:tc hMerge="1">
+                  <a:txBody>
+                    <a:bodyPr/>
+                    <a:lstStyle/>
+                    <a:p/>
+                  </a:txBody>
+                  <a:tcPr/>
+                </a:tc>
+                <a:tc hMerge="1">
+                  <a:txBody>
+                    <a:bodyPr/>
+                    <a:lstStyle/>
+                    <a:p/>
+                  </a:txBody>
+                  <a:tcPr/>
+                </a:tc>
+              </a:tr>
+              <a:tr h="914400">
                 <a:tc>
                   <a:txBody>
                     <a:bodyPr/>
@@ -3327,7 +3391,7 @@
                   <a:tcPr/>
                 </a:tc>
               </a:tr>
-              <a:tr h="975360">
+              <a:tr h="914400">
                 <a:tc>
                   <a:txBody>
                     <a:bodyPr/>
@@ -3365,7 +3429,7 @@
                   <a:tcPr/>
                 </a:tc>
               </a:tr>
-              <a:tr h="975360">
+              <a:tr h="914400">
                 <a:tc>
                   <a:txBody>
                     <a:bodyPr/>

</xml_diff>